<commit_message>
Atualizando SLIDES e BACKUP
</commit_message>
<xml_diff>
--- a/tcc/TCC - Slides.pptx
+++ b/tcc/TCC - Slides.pptx
@@ -37,26 +37,19 @@
       <p:regular r:id="rId20"/>
     </p:embeddedFont>
     <p:embeddedFont>
-      <p:font typeface="Calibri" panose="020F0502020204030204" pitchFamily="34" charset="0"/>
+      <p:font typeface="Gill Sans Bold" panose="020B0604020202020204" charset="0"/>
       <p:regular r:id="rId21"/>
-      <p:bold r:id="rId22"/>
-      <p:italic r:id="rId23"/>
-      <p:boldItalic r:id="rId24"/>
     </p:embeddedFont>
     <p:embeddedFont>
-      <p:font typeface="Gill Sans Bold" panose="020B0604020202020204" charset="0"/>
-      <p:regular r:id="rId25"/>
+      <p:font typeface="Noto Sans" panose="020B0502040204020203" pitchFamily="34" charset="0"/>
+      <p:regular r:id="rId22"/>
+      <p:bold r:id="rId23"/>
+      <p:italic r:id="rId24"/>
+      <p:boldItalic r:id="rId25"/>
     </p:embeddedFont>
     <p:embeddedFont>
-      <p:font typeface="Noto Sans" panose="020B0502040504020204" pitchFamily="34" charset="0"/>
+      <p:font typeface="Noto Sans Bold" panose="020B0604020202020204" charset="0"/>
       <p:regular r:id="rId26"/>
-      <p:bold r:id="rId27"/>
-      <p:italic r:id="rId28"/>
-      <p:boldItalic r:id="rId29"/>
-    </p:embeddedFont>
-    <p:embeddedFont>
-      <p:font typeface="Noto Sans Bold" panose="020B0802040504020204" charset="0"/>
-      <p:regular r:id="rId30"/>
     </p:embeddedFont>
   </p:embeddedFontLst>
   <p:defaultTextStyle>
@@ -617,8 +610,8 @@
         </p:nvSpPr>
         <p:spPr>
           <a:xfrm>
-            <a:off x="2857500" y="512763"/>
-            <a:ext cx="3429000" cy="2566987"/>
+            <a:off x="2290763" y="512763"/>
+            <a:ext cx="4562475" cy="2566987"/>
           </a:xfrm>
           <a:prstGeom prst="rect">
             <a:avLst/>
@@ -5581,104 +5574,6 @@
           </p:spPr>
         </p:sp>
       </p:grpSp>
-      <p:sp>
-        <p:nvSpPr>
-          <p:cNvPr id="8" name="TextBox 8"/>
-          <p:cNvSpPr txBox="1"/>
-          <p:nvPr/>
-        </p:nvSpPr>
-        <p:spPr>
-          <a:xfrm>
-            <a:off x="4437875" y="771144"/>
-            <a:ext cx="13180327" cy="900140"/>
-          </a:xfrm>
-          <a:prstGeom prst="rect">
-            <a:avLst/>
-          </a:prstGeom>
-        </p:spPr>
-        <p:txBody>
-          <a:bodyPr lIns="0" tIns="0" rIns="0" bIns="0" rtlCol="0" anchor="t">
-            <a:spAutoFit/>
-          </a:bodyPr>
-          <a:lstStyle/>
-          <a:p>
-            <a:pPr algn="l">
-              <a:lnSpc>
-                <a:spcPts val="6937"/>
-              </a:lnSpc>
-            </a:pPr>
-            <a:r>
-              <a:rPr lang="en-US" sz="5562" dirty="0" err="1">
-                <a:solidFill>
-                  <a:srgbClr val="000000"/>
-                </a:solidFill>
-                <a:latin typeface="Arimo"/>
-                <a:ea typeface="Arimo"/>
-                <a:cs typeface="Arimo"/>
-                <a:sym typeface="Arimo"/>
-              </a:rPr>
-              <a:t>Defesa</a:t>
-            </a:r>
-            <a:r>
-              <a:rPr lang="en-US" sz="5562" dirty="0">
-                <a:solidFill>
-                  <a:srgbClr val="000000"/>
-                </a:solidFill>
-                <a:latin typeface="Arimo"/>
-                <a:ea typeface="Arimo"/>
-                <a:cs typeface="Arimo"/>
-                <a:sym typeface="Arimo"/>
-              </a:rPr>
-              <a:t> de TCC - </a:t>
-            </a:r>
-            <a:r>
-              <a:rPr lang="en-US" sz="5562" dirty="0" err="1">
-                <a:solidFill>
-                  <a:srgbClr val="000000"/>
-                </a:solidFill>
-                <a:latin typeface="Arimo"/>
-                <a:ea typeface="Arimo"/>
-                <a:cs typeface="Arimo"/>
-                <a:sym typeface="Arimo"/>
-              </a:rPr>
-              <a:t>Sistemas</a:t>
-            </a:r>
-            <a:r>
-              <a:rPr lang="en-US" sz="5562" dirty="0">
-                <a:solidFill>
-                  <a:srgbClr val="000000"/>
-                </a:solidFill>
-                <a:latin typeface="Arimo"/>
-                <a:ea typeface="Arimo"/>
-                <a:cs typeface="Arimo"/>
-                <a:sym typeface="Arimo"/>
-              </a:rPr>
-              <a:t> de </a:t>
-            </a:r>
-            <a:r>
-              <a:rPr lang="en-US" sz="5562" dirty="0" err="1">
-                <a:solidFill>
-                  <a:srgbClr val="000000"/>
-                </a:solidFill>
-                <a:latin typeface="Arimo"/>
-                <a:ea typeface="Arimo"/>
-                <a:cs typeface="Arimo"/>
-                <a:sym typeface="Arimo"/>
-              </a:rPr>
-              <a:t>Informação</a:t>
-            </a:r>
-            <a:endParaRPr lang="en-US" sz="5562" dirty="0">
-              <a:solidFill>
-                <a:srgbClr val="000000"/>
-              </a:solidFill>
-              <a:latin typeface="Arimo"/>
-              <a:ea typeface="Arimo"/>
-              <a:cs typeface="Arimo"/>
-              <a:sym typeface="Arimo"/>
-            </a:endParaRPr>
-          </a:p>
-        </p:txBody>
-      </p:sp>
       <p:sp>
         <p:nvSpPr>
           <p:cNvPr id="9" name="TextBox 9"/>

</xml_diff>